<commit_message>
Module 1: team formation + OpenSpec hands-on scaffold, Tool Reference handout
Co-Authored-By: Claude Sonnet 5 <noreply@anthropic.com>
</commit_message>
<xml_diff>
--- a/presentation/Module-1_From-Vibe-Coding-to-Spec-Driven-Development.pptx
+++ b/presentation/Module-1_From-Vibe-Coding-to-Spec-Driven-Development.pptx
@@ -16,10 +16,9 @@
     <p:sldId id="264" r:id="rId10"/>
     <p:sldId id="265" r:id="rId11"/>
     <p:sldId id="266" r:id="rId12"/>
-    <p:sldId id="267" r:id="rId13"/>
   </p:sldIdLst>
   <p:notesMasterIdLst>
-    <p:notesMasterId r:id="rId14"/>
+    <p:notesMasterId r:id="rId13"/>
   </p:notesMasterIdLst>
   <p:sldSz cx="12192000" cy="6858000"/>
   <p:notesSz cx="6858000" cy="12192000"/>
@@ -713,94 +712,6 @@
             <a:fld id="{F7021451-1387-4CA6-816F-3879F97B5CBC}" type="slidenum">
               <a:rPr lang="en-US"/>
               <a:t>11</a:t>
-            </a:fld>
-            <a:endParaRPr lang="en-US"/>
-          </a:p>
-        </p:txBody>
-      </p:sp>
-    </p:spTree>
-    <p:extLst>
-      <p:ext uri="{BB962C8B-B14F-4D97-AF65-F5344CB8AC3E}">
-        <p14:creationId xmlns:p14="http://schemas.microsoft.com/office/powerpoint/2010/main" val="1024086991"/>
-      </p:ext>
-    </p:extLst>
-  </p:cSld>
-  <p:clrMapOvr>
-    <a:masterClrMapping/>
-  </p:clrMapOvr>
-</p:notes>
-</file>
-
-<file path=ppt/notesSlides/notesSlide12.xml><?xml version="1.0" encoding="utf-8"?>
-<p:notes xmlns:a="http://schemas.openxmlformats.org/drawingml/2006/main" xmlns:r="http://schemas.openxmlformats.org/officeDocument/2006/relationships" xmlns:p="http://schemas.openxmlformats.org/presentationml/2006/main">
-  <p:cSld>
-    <p:spTree>
-      <p:nvGrpSpPr>
-        <p:cNvPr id="1" name=""/>
-        <p:cNvGrpSpPr/>
-        <p:nvPr/>
-      </p:nvGrpSpPr>
-      <p:grpSpPr>
-        <a:xfrm>
-          <a:off x="0" y="0"/>
-          <a:ext cx="0" cy="0"/>
-          <a:chOff x="0" y="0"/>
-          <a:chExt cx="0" cy="0"/>
-        </a:xfrm>
-      </p:grpSpPr>
-      <p:sp>
-        <p:nvSpPr>
-          <p:cNvPr id="2" name="Slide Image Placeholder 1"/>
-          <p:cNvSpPr>
-            <a:spLocks noGrp="1" noRot="1" noChangeAspect="1"/>
-          </p:cNvSpPr>
-          <p:nvPr>
-            <p:ph type="sldImg"/>
-          </p:nvPr>
-        </p:nvSpPr>
-        <p:spPr/>
-      </p:sp>
-      <p:sp>
-        <p:nvSpPr>
-          <p:cNvPr id="3" name="Notes Placeholder 2"/>
-          <p:cNvSpPr>
-            <a:spLocks noGrp="1"/>
-          </p:cNvSpPr>
-          <p:nvPr>
-            <p:ph type="body" idx="1"/>
-          </p:nvPr>
-        </p:nvSpPr>
-        <p:spPr/>
-        <p:txBody>
-          <a:bodyPr/>
-          <a:lstStyle/>
-          <a:p>
-            <a:r>
-              <a:rPr lang="en-US" dirty="0"/>
-              <a:t/>
-            </a:r>
-            <a:endParaRPr lang="en-US" dirty="0"/>
-          </a:p>
-        </p:txBody>
-      </p:sp>
-      <p:sp>
-        <p:nvSpPr>
-          <p:cNvPr id="4" name="Slide Number Placeholder 3"/>
-          <p:cNvSpPr>
-            <a:spLocks noGrp="1"/>
-          </p:cNvSpPr>
-          <p:nvPr>
-            <p:ph type="sldNum" sz="quarter" idx="10"/>
-          </p:nvPr>
-        </p:nvSpPr>
-        <p:spPr/>
-        <p:txBody>
-          <a:bodyPr/>
-          <a:lstStyle/>
-          <a:p>
-            <a:fld id="{F7021451-1387-4CA6-816F-3879F97B5CBC}" type="slidenum">
-              <a:rPr lang="en-US"/>
-              <a:t>12</a:t>
             </a:fld>
             <a:endParaRPr lang="en-US"/>
           </a:p>
@@ -3384,260 +3295,6 @@
 </p:sld>
 </file>
 
-<file path=ppt/slides/slide12.xml><?xml version="1.0" encoding="utf-8"?>
-<p:sld xmlns:a="http://schemas.openxmlformats.org/drawingml/2006/main" xmlns:r="http://schemas.openxmlformats.org/officeDocument/2006/relationships" xmlns:p="http://schemas.openxmlformats.org/presentationml/2006/main">
-  <p:cSld name="Slide 12">
-    <p:bg>
-      <p:bgPr>
-        <a:solidFill>
-          <a:srgbClr val="FFFFFF"/>
-        </a:solidFill>
-      </p:bgPr>
-    </p:bg>
-    <p:spTree>
-      <p:nvGrpSpPr>
-        <p:cNvPr id="1" name=""/>
-        <p:cNvGrpSpPr/>
-        <p:nvPr/>
-      </p:nvGrpSpPr>
-      <p:grpSpPr>
-        <a:xfrm>
-          <a:off x="0" y="0"/>
-          <a:ext cx="0" cy="0"/>
-          <a:chOff x="0" y="0"/>
-          <a:chExt cx="0" cy="0"/>
-        </a:xfrm>
-      </p:grpSpPr>
-      <p:sp>
-        <p:nvSpPr>
-          <p:cNvPr id="2" name="Shape 0"/>
-          <p:cNvSpPr/>
-          <p:nvPr/>
-        </p:nvSpPr>
-        <p:spPr>
-          <a:xfrm>
-            <a:off x="548640" y="1828800"/>
-            <a:ext cx="11094415" cy="2377440"/>
-          </a:xfrm>
-          <a:prstGeom prst="roundRect">
-            <a:avLst>
-              <a:gd name="adj" fmla="val 4615"/>
-            </a:avLst>
-          </a:prstGeom>
-          <a:solidFill>
-            <a:srgbClr val="F2F5F9"/>
-          </a:solidFill>
-          <a:ln w="15875">
-            <a:solidFill>
-              <a:srgbClr val="C0504D"/>
-            </a:solidFill>
-            <a:prstDash val="solid"/>
-          </a:ln>
-        </p:spPr>
-      </p:sp>
-      <p:sp>
-        <p:nvSpPr>
-          <p:cNvPr id="3" name="Text 1"/>
-          <p:cNvSpPr/>
-          <p:nvPr/>
-        </p:nvSpPr>
-        <p:spPr>
-          <a:xfrm>
-            <a:off x="1005840" y="2103120"/>
-            <a:ext cx="10180015" cy="365760"/>
-          </a:xfrm>
-          <a:prstGeom prst="rect">
-            <a:avLst/>
-          </a:prstGeom>
-          <a:noFill/>
-          <a:ln/>
-        </p:spPr>
-        <p:txBody>
-          <a:bodyPr wrap="square" rtlCol="0" anchor="ctr"/>
-          <a:lstStyle/>
-          <a:p>
-            <a:pPr indent="0" marL="0">
-              <a:buNone/>
-            </a:pPr>
-            <a:r>
-              <a:rPr lang="en-US" sz="1300" b="1" spc="150" kern="0" dirty="0">
-                <a:solidFill>
-                  <a:srgbClr val="C0504D"/>
-                </a:solidFill>
-                <a:latin typeface="Calibri" pitchFamily="34" charset="0"/>
-                <a:ea typeface="Calibri" pitchFamily="34" charset="-122"/>
-                <a:cs typeface="Calibri" pitchFamily="34" charset="-120"/>
-              </a:rPr>
-              <a:t>HANDS-ON NEXT</a:t>
-            </a:r>
-            <a:endParaRPr lang="en-US" sz="1300" dirty="0"/>
-          </a:p>
-        </p:txBody>
-      </p:sp>
-      <p:sp>
-        <p:nvSpPr>
-          <p:cNvPr id="4" name="Text 2"/>
-          <p:cNvSpPr/>
-          <p:nvPr/>
-        </p:nvSpPr>
-        <p:spPr>
-          <a:xfrm>
-            <a:off x="1005840" y="2514600"/>
-            <a:ext cx="10180015" cy="1463040"/>
-          </a:xfrm>
-          <a:prstGeom prst="rect">
-            <a:avLst/>
-          </a:prstGeom>
-          <a:noFill/>
-          <a:ln/>
-        </p:spPr>
-        <p:txBody>
-          <a:bodyPr wrap="square" rtlCol="0" anchor="t"/>
-          <a:lstStyle/>
-          <a:p>
-            <a:pPr indent="0" marL="0">
-              <a:buNone/>
-            </a:pPr>
-            <a:r>
-              <a:rPr lang="en-US" sz="1700" dirty="0">
-                <a:solidFill>
-                  <a:srgbClr val="1B2A4A"/>
-                </a:solidFill>
-                <a:latin typeface="Calibri" pitchFamily="34" charset="0"/>
-                <a:ea typeface="Calibri" pitchFamily="34" charset="-122"/>
-                <a:cs typeface="Calibri" pitchFamily="34" charset="-120"/>
-              </a:rPr>
-              <a:t>Form your project team, receive your team's assigned requirement, and set up your agentic coding tool against it. Scaffold both a Spec Kit specs/ directory and an OpenSpec openspec/ directory, then run a basic and an advanced prompt to compare direct prompting against structured, spec-driven input.</a:t>
-            </a:r>
-            <a:endParaRPr lang="en-US" sz="1700" dirty="0"/>
-          </a:p>
-        </p:txBody>
-      </p:sp>
-      <p:sp>
-        <p:nvSpPr>
-          <p:cNvPr id="5" name="Text 3"/>
-          <p:cNvSpPr/>
-          <p:nvPr/>
-        </p:nvSpPr>
-        <p:spPr>
-          <a:xfrm>
-            <a:off x="548640" y="4480560"/>
-            <a:ext cx="11094415" cy="457200"/>
-          </a:xfrm>
-          <a:prstGeom prst="rect">
-            <a:avLst/>
-          </a:prstGeom>
-          <a:noFill/>
-          <a:ln/>
-        </p:spPr>
-        <p:txBody>
-          <a:bodyPr wrap="square" rtlCol="0" anchor="ctr"/>
-          <a:lstStyle/>
-          <a:p>
-            <a:pPr algn="ctr" indent="0" marL="0">
-              <a:buNone/>
-            </a:pPr>
-            <a:r>
-              <a:rPr lang="en-US" sz="1300" i="1" dirty="0">
-                <a:solidFill>
-                  <a:srgbClr val="5A6B85"/>
-                </a:solidFill>
-                <a:latin typeface="Calibri" pitchFamily="34" charset="0"/>
-                <a:ea typeface="Calibri" pitchFamily="34" charset="-122"/>
-                <a:cs typeface="Calibri" pitchFamily="34" charset="-120"/>
-              </a:rPr>
-              <a:t>Next: Module 2: Discovery at Scale: Understanding an Existing Hierarchical Codebase</a:t>
-            </a:r>
-            <a:endParaRPr lang="en-US" sz="1300" dirty="0"/>
-          </a:p>
-        </p:txBody>
-      </p:sp>
-      <p:sp>
-        <p:nvSpPr>
-          <p:cNvPr id="6" name="Text 4"/>
-          <p:cNvSpPr/>
-          <p:nvPr/>
-        </p:nvSpPr>
-        <p:spPr>
-          <a:xfrm>
-            <a:off x="548640" y="6473952"/>
-            <a:ext cx="5486400" cy="274320"/>
-          </a:xfrm>
-          <a:prstGeom prst="rect">
-            <a:avLst/>
-          </a:prstGeom>
-          <a:noFill/>
-          <a:ln/>
-        </p:spPr>
-        <p:txBody>
-          <a:bodyPr wrap="square" rtlCol="0" anchor="ctr"/>
-          <a:lstStyle/>
-          <a:p>
-            <a:pPr algn="l" indent="0" marL="0">
-              <a:buNone/>
-            </a:pPr>
-            <a:r>
-              <a:rPr lang="en-US" sz="1000" dirty="0">
-                <a:solidFill>
-                  <a:srgbClr val="5A6B85"/>
-                </a:solidFill>
-                <a:latin typeface="Calibri" pitchFamily="34" charset="0"/>
-                <a:ea typeface="Calibri" pitchFamily="34" charset="-122"/>
-                <a:cs typeface="Calibri" pitchFamily="34" charset="-120"/>
-              </a:rPr>
-              <a:t>Module 1</a:t>
-            </a:r>
-            <a:endParaRPr lang="en-US" sz="1000" dirty="0"/>
-          </a:p>
-        </p:txBody>
-      </p:sp>
-      <p:sp>
-        <p:nvSpPr>
-          <p:cNvPr id="7" name="Text 5"/>
-          <p:cNvSpPr/>
-          <p:nvPr/>
-        </p:nvSpPr>
-        <p:spPr>
-          <a:xfrm>
-            <a:off x="6156655" y="6473952"/>
-            <a:ext cx="5486400" cy="274320"/>
-          </a:xfrm>
-          <a:prstGeom prst="rect">
-            <a:avLst/>
-          </a:prstGeom>
-          <a:noFill/>
-          <a:ln/>
-        </p:spPr>
-        <p:txBody>
-          <a:bodyPr wrap="square" rtlCol="0" anchor="ctr"/>
-          <a:lstStyle/>
-          <a:p>
-            <a:pPr algn="r" indent="0" marL="0">
-              <a:buNone/>
-            </a:pPr>
-            <a:r>
-              <a:rPr lang="en-US" sz="1000" dirty="0">
-                <a:solidFill>
-                  <a:srgbClr val="5A6B85"/>
-                </a:solidFill>
-                <a:latin typeface="Calibri" pitchFamily="34" charset="0"/>
-                <a:ea typeface="Calibri" pitchFamily="34" charset="-122"/>
-                <a:cs typeface="Calibri" pitchFamily="34" charset="-120"/>
-              </a:rPr>
-              <a:t>Spec-Driven Development with Agentic AI</a:t>
-            </a:r>
-            <a:endParaRPr lang="en-US" sz="1000" dirty="0"/>
-          </a:p>
-        </p:txBody>
-      </p:sp>
-    </p:spTree>
-  </p:cSld>
-  <p:clrMapOvr>
-    <a:masterClrMapping/>
-  </p:clrMapOvr>
-</p:sld>
-</file>
-
 <file path=ppt/slides/slide2.xml><?xml version="1.0" encoding="utf-8"?>
 <p:sld xmlns:a="http://schemas.openxmlformats.org/drawingml/2006/main" xmlns:r="http://schemas.openxmlformats.org/officeDocument/2006/relationships" xmlns:p="http://schemas.openxmlformats.org/presentationml/2006/main">
   <p:cSld name="Slide 2">
@@ -5416,7 +5073,7 @@
                 <a:ea typeface="Calibri" pitchFamily="34" charset="-122"/>
                 <a:cs typeface="Calibri" pitchFamily="34" charset="-120"/>
               </a:rPr>
-              <a:t>GitHub Spec Kit, OpenSpec, AWS Kiro, BMAD-METHOD, and Tessl all put a written spec ahead of code.</a:t>
+              <a:t>GitHub Spec Kit, OpenSpec, Kiro, BMAD-METHOD, and Tessl all put a written spec ahead of code.</a:t>
             </a:r>
             <a:endParaRPr lang="en-US" sz="1500" dirty="0"/>
           </a:p>
@@ -5477,7 +5134,7 @@
                 <a:ea typeface="Calibri" pitchFamily="34" charset="-122"/>
                 <a:cs typeface="Calibri" pitchFamily="34" charset="-120"/>
               </a:rPr>
-              <a:t>This course teaches two hands-on: Spec Kit as the primary framework, OpenSpec for comparison.</a:t>
+              <a:t>This course uses Spec Kit as the hands-on framework for its vendor-neutral, CLI-first design, with a side-by-side look at OpenSpec today.</a:t>
             </a:r>
             <a:endParaRPr lang="en-US" sz="1500" dirty="0"/>
           </a:p>
@@ -6133,7 +5790,7 @@
                 <a:ea typeface="Calibri" pitchFamily="34" charset="-122"/>
                 <a:cs typeface="Calibri" pitchFamily="34" charset="-120"/>
               </a:rPr>
-              <a:t>The full command chain this course follows: constitution → specify → clarify → plan → checklist → tasks → analyze → implement → converge. This is your map for the next eight modules.</a:t>
+              <a:t>The full SDD lifecycle this course follows: constitution, specify, clarify, plan, tasks, checklist, analyze, implement. This is the map for the rest of the course.</a:t>
             </a:r>
             <a:endParaRPr lang="en-US" sz="1400" dirty="0"/>
           </a:p>
@@ -6803,7 +6460,7 @@
                 <a:ea typeface="Calibri" pitchFamily="34" charset="-122"/>
                 <a:cs typeface="Calibri" pitchFamily="34" charset="-120"/>
               </a:rPr>
-              <a:t>Default quick path: explore (optional) → propose → apply → sync (optional) → archive.</a:t>
+              <a:t>Default quick path: explore (optional), propose, apply, sync (optional), archive.</a:t>
             </a:r>
             <a:endParaRPr lang="en-US" sz="1400" dirty="0"/>
           </a:p>

</xml_diff>

<commit_message>
Add mcp-setup.md and setup-guide.md; wire into demo/README.md, Module 1, and Module 2
Co-Authored-By: Claude Sonnet 5 <noreply@anthropic.com>
</commit_message>
<xml_diff>
--- a/presentation/Module-1_From-Vibe-Coding-to-Spec-Driven-Development.pptx
+++ b/presentation/Module-1_From-Vibe-Coding-to-Spec-Driven-Development.pptx
@@ -1456,6 +1456,54 @@
           <a:chExt cx="0" cy="0"/>
         </a:xfrm>
       </p:grpSpPr>
+      <p:sp>
+        <p:nvSpPr>
+          <p:cNvPr id="25" name="Slide Number Placeholder 0"/>
+          <p:cNvSpPr>
+            <a:spLocks noGrp="1"/>
+          </p:cNvSpPr>
+          <p:nvPr>
+            <p:ph type="sldNum" sz="quarter" idx="4294967295"/>
+          </p:nvPr>
+        </p:nvSpPr>
+        <p:spPr>
+          <a:xfrm>
+            <a:off x="5821528" y="6473952"/>
+            <a:ext cx="548640" cy="274320"/>
+          </a:xfrm>
+          <a:prstGeom prst="rect">
+            <a:avLst/>
+          </a:prstGeom>
+          <a:extLst>
+            <a:ext uri="{C572A759-6A51-4108-AA02-DFA0A04FC94B}">
+              <ma14:wrappingTextBoxFlag xmlns:ma14="http://schemas.microsoft.com/office/mac/drawingml/2011/main" val="0"/>
+            </a:ext>
+          </a:extLst>
+        </p:spPr>
+        <p:txBody>
+          <a:bodyPr anchor="ctr"/>
+          <a:lstStyle>
+            <a:lvl1pPr>
+              <a:defRPr sz="1000">
+                <a:solidFill>
+                  <a:srgbClr val="8CA3C7"/>
+                </a:solidFill>
+                <a:latin typeface="Calibri"/>
+                <a:ea typeface="Calibri"/>
+                <a:cs typeface="Calibri"/>
+              </a:defRPr>
+            </a:lvl1pPr>
+          </a:lstStyle>
+          <a:p>
+            <a:pPr algn="ctr"/>
+            <a:fld id="{F7021451-1387-4CA6-816F-3879F97B5CBC}" type="slidenum">
+              <a:rPr b="0" lang="en-US"/>
+              <a:t>1000</a:t>
+            </a:fld>
+            <a:endParaRPr lang="en-US"/>
+          </a:p>
+        </p:txBody>
+      </p:sp>
     </p:spTree>
   </p:cSld>
   <p:clrMapOvr>
@@ -1481,6 +1529,54 @@
           <a:chExt cx="0" cy="0"/>
         </a:xfrm>
       </p:grpSpPr>
+      <p:sp>
+        <p:nvSpPr>
+          <p:cNvPr id="25" name="Slide Number Placeholder 0"/>
+          <p:cNvSpPr>
+            <a:spLocks noGrp="1"/>
+          </p:cNvSpPr>
+          <p:nvPr>
+            <p:ph type="sldNum" sz="quarter" idx="4294967295"/>
+          </p:nvPr>
+        </p:nvSpPr>
+        <p:spPr>
+          <a:xfrm>
+            <a:off x="5821528" y="6473952"/>
+            <a:ext cx="548640" cy="274320"/>
+          </a:xfrm>
+          <a:prstGeom prst="rect">
+            <a:avLst/>
+          </a:prstGeom>
+          <a:extLst>
+            <a:ext uri="{C572A759-6A51-4108-AA02-DFA0A04FC94B}">
+              <ma14:wrappingTextBoxFlag xmlns:ma14="http://schemas.microsoft.com/office/mac/drawingml/2011/main" val="0"/>
+            </a:ext>
+          </a:extLst>
+        </p:spPr>
+        <p:txBody>
+          <a:bodyPr anchor="ctr"/>
+          <a:lstStyle>
+            <a:lvl1pPr>
+              <a:defRPr sz="1000">
+                <a:solidFill>
+                  <a:srgbClr val="8CA3C7"/>
+                </a:solidFill>
+                <a:latin typeface="Calibri"/>
+                <a:ea typeface="Calibri"/>
+                <a:cs typeface="Calibri"/>
+              </a:defRPr>
+            </a:lvl1pPr>
+          </a:lstStyle>
+          <a:p>
+            <a:pPr algn="ctr"/>
+            <a:fld id="{F7021451-1387-4CA6-816F-3879F97B5CBC}" type="slidenum">
+              <a:rPr b="0" lang="en-US"/>
+              <a:t>null</a:t>
+            </a:fld>
+            <a:endParaRPr lang="en-US"/>
+          </a:p>
+        </p:txBody>
+      </p:sp>
     </p:spTree>
   </p:cSld>
   <p:clrMap bg1="lt1" tx1="dk1" bg2="lt2" tx2="dk2" accent1="accent1" accent2="accent2" accent3="accent3" accent4="accent4" accent5="accent5" accent6="accent6" hlink="hlink" folHlink="folHlink"/>
@@ -1983,6 +2079,54 @@
               <a:t>Why unstructured AI prompting breaks down, and what spec-driven development changes.</a:t>
             </a:r>
             <a:endParaRPr lang="en-US" sz="1800" dirty="0"/>
+          </a:p>
+        </p:txBody>
+      </p:sp>
+      <p:sp>
+        <p:nvSpPr>
+          <p:cNvPr id="25" name="Slide Number Placeholder 0"/>
+          <p:cNvSpPr>
+            <a:spLocks noGrp="1"/>
+          </p:cNvSpPr>
+          <p:nvPr>
+            <p:ph type="sldNum" sz="quarter" idx="4294967295"/>
+          </p:nvPr>
+        </p:nvSpPr>
+        <p:spPr>
+          <a:xfrm>
+            <a:off x="5821528" y="6473952"/>
+            <a:ext cx="548640" cy="274320"/>
+          </a:xfrm>
+          <a:prstGeom prst="rect">
+            <a:avLst/>
+          </a:prstGeom>
+          <a:extLst>
+            <a:ext uri="{C572A759-6A51-4108-AA02-DFA0A04FC94B}">
+              <ma14:wrappingTextBoxFlag xmlns:ma14="http://schemas.microsoft.com/office/mac/drawingml/2011/main" val="0"/>
+            </a:ext>
+          </a:extLst>
+        </p:spPr>
+        <p:txBody>
+          <a:bodyPr anchor="ctr"/>
+          <a:lstStyle>
+            <a:lvl1pPr>
+              <a:defRPr sz="1000">
+                <a:solidFill>
+                  <a:srgbClr val="8CA3C7"/>
+                </a:solidFill>
+                <a:latin typeface="Calibri"/>
+                <a:ea typeface="Calibri"/>
+                <a:cs typeface="Calibri"/>
+              </a:defRPr>
+            </a:lvl1pPr>
+          </a:lstStyle>
+          <a:p>
+            <a:pPr algn="ctr"/>
+            <a:fld id="{F7021451-1387-4CA6-816F-3879F97B5CBC}" type="slidenum">
+              <a:rPr b="0" lang="en-US"/>
+              <a:t>1</a:t>
+            </a:fld>
+            <a:endParaRPr lang="en-US"/>
           </a:p>
         </p:txBody>
       </p:sp>
@@ -2961,6 +3105,54 @@
           </a:p>
         </p:txBody>
       </p:sp>
+      <p:sp>
+        <p:nvSpPr>
+          <p:cNvPr id="25" name="Slide Number Placeholder 0"/>
+          <p:cNvSpPr>
+            <a:spLocks noGrp="1"/>
+          </p:cNvSpPr>
+          <p:nvPr>
+            <p:ph type="sldNum" sz="quarter" idx="4294967295"/>
+          </p:nvPr>
+        </p:nvSpPr>
+        <p:spPr>
+          <a:xfrm>
+            <a:off x="5821528" y="6473952"/>
+            <a:ext cx="548640" cy="274320"/>
+          </a:xfrm>
+          <a:prstGeom prst="rect">
+            <a:avLst/>
+          </a:prstGeom>
+          <a:extLst>
+            <a:ext uri="{C572A759-6A51-4108-AA02-DFA0A04FC94B}">
+              <ma14:wrappingTextBoxFlag xmlns:ma14="http://schemas.microsoft.com/office/mac/drawingml/2011/main" val="0"/>
+            </a:ext>
+          </a:extLst>
+        </p:spPr>
+        <p:txBody>
+          <a:bodyPr anchor="ctr"/>
+          <a:lstStyle>
+            <a:lvl1pPr>
+              <a:defRPr sz="1000">
+                <a:solidFill>
+                  <a:srgbClr val="5A6B85"/>
+                </a:solidFill>
+                <a:latin typeface="Calibri"/>
+                <a:ea typeface="Calibri"/>
+                <a:cs typeface="Calibri"/>
+              </a:defRPr>
+            </a:lvl1pPr>
+          </a:lstStyle>
+          <a:p>
+            <a:pPr algn="ctr"/>
+            <a:fld id="{F7021451-1387-4CA6-816F-3879F97B5CBC}" type="slidenum">
+              <a:rPr b="0" lang="en-US"/>
+              <a:t>10</a:t>
+            </a:fld>
+            <a:endParaRPr lang="en-US"/>
+          </a:p>
+        </p:txBody>
+      </p:sp>
     </p:spTree>
   </p:cSld>
   <p:clrMapOvr>
@@ -3287,6 +3479,54 @@
           </a:p>
         </p:txBody>
       </p:sp>
+      <p:sp>
+        <p:nvSpPr>
+          <p:cNvPr id="25" name="Slide Number Placeholder 0"/>
+          <p:cNvSpPr>
+            <a:spLocks noGrp="1"/>
+          </p:cNvSpPr>
+          <p:nvPr>
+            <p:ph type="sldNum" sz="quarter" idx="4294967295"/>
+          </p:nvPr>
+        </p:nvSpPr>
+        <p:spPr>
+          <a:xfrm>
+            <a:off x="5821528" y="6473952"/>
+            <a:ext cx="548640" cy="274320"/>
+          </a:xfrm>
+          <a:prstGeom prst="rect">
+            <a:avLst/>
+          </a:prstGeom>
+          <a:extLst>
+            <a:ext uri="{C572A759-6A51-4108-AA02-DFA0A04FC94B}">
+              <ma14:wrappingTextBoxFlag xmlns:ma14="http://schemas.microsoft.com/office/mac/drawingml/2011/main" val="0"/>
+            </a:ext>
+          </a:extLst>
+        </p:spPr>
+        <p:txBody>
+          <a:bodyPr anchor="ctr"/>
+          <a:lstStyle>
+            <a:lvl1pPr>
+              <a:defRPr sz="1000">
+                <a:solidFill>
+                  <a:srgbClr val="8CA3C7"/>
+                </a:solidFill>
+                <a:latin typeface="Calibri"/>
+                <a:ea typeface="Calibri"/>
+                <a:cs typeface="Calibri"/>
+              </a:defRPr>
+            </a:lvl1pPr>
+          </a:lstStyle>
+          <a:p>
+            <a:pPr algn="ctr"/>
+            <a:fld id="{F7021451-1387-4CA6-816F-3879F97B5CBC}" type="slidenum">
+              <a:rPr b="0" lang="en-US"/>
+              <a:t>11</a:t>
+            </a:fld>
+            <a:endParaRPr lang="en-US"/>
+          </a:p>
+        </p:txBody>
+      </p:sp>
     </p:spTree>
   </p:cSld>
   <p:clrMapOvr>
@@ -3828,6 +4068,54 @@
           </a:p>
         </p:txBody>
       </p:sp>
+      <p:sp>
+        <p:nvSpPr>
+          <p:cNvPr id="25" name="Slide Number Placeholder 0"/>
+          <p:cNvSpPr>
+            <a:spLocks noGrp="1"/>
+          </p:cNvSpPr>
+          <p:nvPr>
+            <p:ph type="sldNum" sz="quarter" idx="4294967295"/>
+          </p:nvPr>
+        </p:nvSpPr>
+        <p:spPr>
+          <a:xfrm>
+            <a:off x="5821528" y="6473952"/>
+            <a:ext cx="548640" cy="274320"/>
+          </a:xfrm>
+          <a:prstGeom prst="rect">
+            <a:avLst/>
+          </a:prstGeom>
+          <a:extLst>
+            <a:ext uri="{C572A759-6A51-4108-AA02-DFA0A04FC94B}">
+              <ma14:wrappingTextBoxFlag xmlns:ma14="http://schemas.microsoft.com/office/mac/drawingml/2011/main" val="0"/>
+            </a:ext>
+          </a:extLst>
+        </p:spPr>
+        <p:txBody>
+          <a:bodyPr anchor="ctr"/>
+          <a:lstStyle>
+            <a:lvl1pPr>
+              <a:defRPr sz="1000">
+                <a:solidFill>
+                  <a:srgbClr val="5A6B85"/>
+                </a:solidFill>
+                <a:latin typeface="Calibri"/>
+                <a:ea typeface="Calibri"/>
+                <a:cs typeface="Calibri"/>
+              </a:defRPr>
+            </a:lvl1pPr>
+          </a:lstStyle>
+          <a:p>
+            <a:pPr algn="ctr"/>
+            <a:fld id="{F7021451-1387-4CA6-816F-3879F97B5CBC}" type="slidenum">
+              <a:rPr b="0" lang="en-US"/>
+              <a:t>2</a:t>
+            </a:fld>
+            <a:endParaRPr lang="en-US"/>
+          </a:p>
+        </p:txBody>
+      </p:sp>
     </p:spTree>
   </p:cSld>
   <p:clrMapOvr>
@@ -4396,6 +4684,54 @@
           </a:p>
         </p:txBody>
       </p:sp>
+      <p:sp>
+        <p:nvSpPr>
+          <p:cNvPr id="25" name="Slide Number Placeholder 0"/>
+          <p:cNvSpPr>
+            <a:spLocks noGrp="1"/>
+          </p:cNvSpPr>
+          <p:nvPr>
+            <p:ph type="sldNum" sz="quarter" idx="4294967295"/>
+          </p:nvPr>
+        </p:nvSpPr>
+        <p:spPr>
+          <a:xfrm>
+            <a:off x="5821528" y="6473952"/>
+            <a:ext cx="548640" cy="274320"/>
+          </a:xfrm>
+          <a:prstGeom prst="rect">
+            <a:avLst/>
+          </a:prstGeom>
+          <a:extLst>
+            <a:ext uri="{C572A759-6A51-4108-AA02-DFA0A04FC94B}">
+              <ma14:wrappingTextBoxFlag xmlns:ma14="http://schemas.microsoft.com/office/mac/drawingml/2011/main" val="0"/>
+            </a:ext>
+          </a:extLst>
+        </p:spPr>
+        <p:txBody>
+          <a:bodyPr anchor="ctr"/>
+          <a:lstStyle>
+            <a:lvl1pPr>
+              <a:defRPr sz="1000">
+                <a:solidFill>
+                  <a:srgbClr val="5A6B85"/>
+                </a:solidFill>
+                <a:latin typeface="Calibri"/>
+                <a:ea typeface="Calibri"/>
+                <a:cs typeface="Calibri"/>
+              </a:defRPr>
+            </a:lvl1pPr>
+          </a:lstStyle>
+          <a:p>
+            <a:pPr algn="ctr"/>
+            <a:fld id="{F7021451-1387-4CA6-816F-3879F97B5CBC}" type="slidenum">
+              <a:rPr b="0" lang="en-US"/>
+              <a:t>3</a:t>
+            </a:fld>
+            <a:endParaRPr lang="en-US"/>
+          </a:p>
+        </p:txBody>
+      </p:sp>
     </p:spTree>
   </p:cSld>
   <p:clrMapOvr>
@@ -4908,6 +5244,54 @@
           </a:p>
         </p:txBody>
       </p:sp>
+      <p:sp>
+        <p:nvSpPr>
+          <p:cNvPr id="25" name="Slide Number Placeholder 0"/>
+          <p:cNvSpPr>
+            <a:spLocks noGrp="1"/>
+          </p:cNvSpPr>
+          <p:nvPr>
+            <p:ph type="sldNum" sz="quarter" idx="4294967295"/>
+          </p:nvPr>
+        </p:nvSpPr>
+        <p:spPr>
+          <a:xfrm>
+            <a:off x="5821528" y="6473952"/>
+            <a:ext cx="548640" cy="274320"/>
+          </a:xfrm>
+          <a:prstGeom prst="rect">
+            <a:avLst/>
+          </a:prstGeom>
+          <a:extLst>
+            <a:ext uri="{C572A759-6A51-4108-AA02-DFA0A04FC94B}">
+              <ma14:wrappingTextBoxFlag xmlns:ma14="http://schemas.microsoft.com/office/mac/drawingml/2011/main" val="0"/>
+            </a:ext>
+          </a:extLst>
+        </p:spPr>
+        <p:txBody>
+          <a:bodyPr anchor="ctr"/>
+          <a:lstStyle>
+            <a:lvl1pPr>
+              <a:defRPr sz="1000">
+                <a:solidFill>
+                  <a:srgbClr val="5A6B85"/>
+                </a:solidFill>
+                <a:latin typeface="Calibri"/>
+                <a:ea typeface="Calibri"/>
+                <a:cs typeface="Calibri"/>
+              </a:defRPr>
+            </a:lvl1pPr>
+          </a:lstStyle>
+          <a:p>
+            <a:pPr algn="ctr"/>
+            <a:fld id="{F7021451-1387-4CA6-816F-3879F97B5CBC}" type="slidenum">
+              <a:rPr b="0" lang="en-US"/>
+              <a:t>4</a:t>
+            </a:fld>
+            <a:endParaRPr lang="en-US"/>
+          </a:p>
+        </p:txBody>
+      </p:sp>
     </p:spTree>
   </p:cSld>
   <p:clrMapOvr>
@@ -5279,6 +5663,54 @@
           </a:p>
         </p:txBody>
       </p:sp>
+      <p:sp>
+        <p:nvSpPr>
+          <p:cNvPr id="25" name="Slide Number Placeholder 0"/>
+          <p:cNvSpPr>
+            <a:spLocks noGrp="1"/>
+          </p:cNvSpPr>
+          <p:nvPr>
+            <p:ph type="sldNum" sz="quarter" idx="4294967295"/>
+          </p:nvPr>
+        </p:nvSpPr>
+        <p:spPr>
+          <a:xfrm>
+            <a:off x="5821528" y="6473952"/>
+            <a:ext cx="548640" cy="274320"/>
+          </a:xfrm>
+          <a:prstGeom prst="rect">
+            <a:avLst/>
+          </a:prstGeom>
+          <a:extLst>
+            <a:ext uri="{C572A759-6A51-4108-AA02-DFA0A04FC94B}">
+              <ma14:wrappingTextBoxFlag xmlns:ma14="http://schemas.microsoft.com/office/mac/drawingml/2011/main" val="0"/>
+            </a:ext>
+          </a:extLst>
+        </p:spPr>
+        <p:txBody>
+          <a:bodyPr anchor="ctr"/>
+          <a:lstStyle>
+            <a:lvl1pPr>
+              <a:defRPr sz="1000">
+                <a:solidFill>
+                  <a:srgbClr val="8CA3C7"/>
+                </a:solidFill>
+                <a:latin typeface="Calibri"/>
+                <a:ea typeface="Calibri"/>
+                <a:cs typeface="Calibri"/>
+              </a:defRPr>
+            </a:lvl1pPr>
+          </a:lstStyle>
+          <a:p>
+            <a:pPr algn="ctr"/>
+            <a:fld id="{F7021451-1387-4CA6-816F-3879F97B5CBC}" type="slidenum">
+              <a:rPr b="0" lang="en-US"/>
+              <a:t>5</a:t>
+            </a:fld>
+            <a:endParaRPr lang="en-US"/>
+          </a:p>
+        </p:txBody>
+      </p:sp>
     </p:spTree>
   </p:cSld>
   <p:clrMapOvr>
@@ -5344,7 +5776,7 @@
                 <a:ea typeface="Calibri" pitchFamily="34" charset="-122"/>
                 <a:cs typeface="Calibri" pitchFamily="34" charset="-120"/>
               </a:rPr>
-              <a:t>APPLYING THIS WITH</a:t>
+              <a:t>APPLYING THE CONCEPTS</a:t>
             </a:r>
             <a:endParaRPr lang="en-US" sz="1400" dirty="0"/>
           </a:p>
@@ -5464,6 +5896,54 @@
               <a:t>Spec-Driven Development with Agentic AI</a:t>
             </a:r>
             <a:endParaRPr lang="en-US" sz="1000" dirty="0"/>
+          </a:p>
+        </p:txBody>
+      </p:sp>
+      <p:sp>
+        <p:nvSpPr>
+          <p:cNvPr id="25" name="Slide Number Placeholder 0"/>
+          <p:cNvSpPr>
+            <a:spLocks noGrp="1"/>
+          </p:cNvSpPr>
+          <p:nvPr>
+            <p:ph type="sldNum" sz="quarter" idx="4294967295"/>
+          </p:nvPr>
+        </p:nvSpPr>
+        <p:spPr>
+          <a:xfrm>
+            <a:off x="5821528" y="6473952"/>
+            <a:ext cx="548640" cy="274320"/>
+          </a:xfrm>
+          <a:prstGeom prst="rect">
+            <a:avLst/>
+          </a:prstGeom>
+          <a:extLst>
+            <a:ext uri="{C572A759-6A51-4108-AA02-DFA0A04FC94B}">
+              <ma14:wrappingTextBoxFlag xmlns:ma14="http://schemas.microsoft.com/office/mac/drawingml/2011/main" val="0"/>
+            </a:ext>
+          </a:extLst>
+        </p:spPr>
+        <p:txBody>
+          <a:bodyPr anchor="ctr"/>
+          <a:lstStyle>
+            <a:lvl1pPr>
+              <a:defRPr sz="1000">
+                <a:solidFill>
+                  <a:srgbClr val="8CA3C7"/>
+                </a:solidFill>
+                <a:latin typeface="Calibri"/>
+                <a:ea typeface="Calibri"/>
+                <a:cs typeface="Calibri"/>
+              </a:defRPr>
+            </a:lvl1pPr>
+          </a:lstStyle>
+          <a:p>
+            <a:pPr algn="ctr"/>
+            <a:fld id="{F7021451-1387-4CA6-816F-3879F97B5CBC}" type="slidenum">
+              <a:rPr b="0" lang="en-US"/>
+              <a:t>6</a:t>
+            </a:fld>
+            <a:endParaRPr lang="en-US"/>
           </a:p>
         </p:txBody>
       </p:sp>
@@ -5949,6 +6429,54 @@
           </a:p>
         </p:txBody>
       </p:sp>
+      <p:sp>
+        <p:nvSpPr>
+          <p:cNvPr id="25" name="Slide Number Placeholder 0"/>
+          <p:cNvSpPr>
+            <a:spLocks noGrp="1"/>
+          </p:cNvSpPr>
+          <p:nvPr>
+            <p:ph type="sldNum" sz="quarter" idx="4294967295"/>
+          </p:nvPr>
+        </p:nvSpPr>
+        <p:spPr>
+          <a:xfrm>
+            <a:off x="5821528" y="6473952"/>
+            <a:ext cx="548640" cy="274320"/>
+          </a:xfrm>
+          <a:prstGeom prst="rect">
+            <a:avLst/>
+          </a:prstGeom>
+          <a:extLst>
+            <a:ext uri="{C572A759-6A51-4108-AA02-DFA0A04FC94B}">
+              <ma14:wrappingTextBoxFlag xmlns:ma14="http://schemas.microsoft.com/office/mac/drawingml/2011/main" val="0"/>
+            </a:ext>
+          </a:extLst>
+        </p:spPr>
+        <p:txBody>
+          <a:bodyPr anchor="ctr"/>
+          <a:lstStyle>
+            <a:lvl1pPr>
+              <a:defRPr sz="1000">
+                <a:solidFill>
+                  <a:srgbClr val="5A6B85"/>
+                </a:solidFill>
+                <a:latin typeface="Calibri"/>
+                <a:ea typeface="Calibri"/>
+                <a:cs typeface="Calibri"/>
+              </a:defRPr>
+            </a:lvl1pPr>
+          </a:lstStyle>
+          <a:p>
+            <a:pPr algn="ctr"/>
+            <a:fld id="{F7021451-1387-4CA6-816F-3879F97B5CBC}" type="slidenum">
+              <a:rPr b="0" lang="en-US"/>
+              <a:t>7</a:t>
+            </a:fld>
+            <a:endParaRPr lang="en-US"/>
+          </a:p>
+        </p:txBody>
+      </p:sp>
     </p:spTree>
   </p:cSld>
   <p:clrMapOvr>
@@ -6014,7 +6542,7 @@
                 <a:ea typeface="Calibri" pitchFamily="34" charset="-122"/>
                 <a:cs typeface="Calibri" pitchFamily="34" charset="-120"/>
               </a:rPr>
-              <a:t>APPLYING THIS WITH</a:t>
+              <a:t>APPLYING THE CONCEPTS</a:t>
             </a:r>
             <a:endParaRPr lang="en-US" sz="1400" dirty="0"/>
           </a:p>
@@ -6134,6 +6662,54 @@
               <a:t>Spec-Driven Development with Agentic AI</a:t>
             </a:r>
             <a:endParaRPr lang="en-US" sz="1000" dirty="0"/>
+          </a:p>
+        </p:txBody>
+      </p:sp>
+      <p:sp>
+        <p:nvSpPr>
+          <p:cNvPr id="25" name="Slide Number Placeholder 0"/>
+          <p:cNvSpPr>
+            <a:spLocks noGrp="1"/>
+          </p:cNvSpPr>
+          <p:nvPr>
+            <p:ph type="sldNum" sz="quarter" idx="4294967295"/>
+          </p:nvPr>
+        </p:nvSpPr>
+        <p:spPr>
+          <a:xfrm>
+            <a:off x="5821528" y="6473952"/>
+            <a:ext cx="548640" cy="274320"/>
+          </a:xfrm>
+          <a:prstGeom prst="rect">
+            <a:avLst/>
+          </a:prstGeom>
+          <a:extLst>
+            <a:ext uri="{C572A759-6A51-4108-AA02-DFA0A04FC94B}">
+              <ma14:wrappingTextBoxFlag xmlns:ma14="http://schemas.microsoft.com/office/mac/drawingml/2011/main" val="0"/>
+            </a:ext>
+          </a:extLst>
+        </p:spPr>
+        <p:txBody>
+          <a:bodyPr anchor="ctr"/>
+          <a:lstStyle>
+            <a:lvl1pPr>
+              <a:defRPr sz="1000">
+                <a:solidFill>
+                  <a:srgbClr val="8CA3C7"/>
+                </a:solidFill>
+                <a:latin typeface="Calibri"/>
+                <a:ea typeface="Calibri"/>
+                <a:cs typeface="Calibri"/>
+              </a:defRPr>
+            </a:lvl1pPr>
+          </a:lstStyle>
+          <a:p>
+            <a:pPr algn="ctr"/>
+            <a:fld id="{F7021451-1387-4CA6-816F-3879F97B5CBC}" type="slidenum">
+              <a:rPr b="0" lang="en-US"/>
+              <a:t>8</a:t>
+            </a:fld>
+            <a:endParaRPr lang="en-US"/>
           </a:p>
         </p:txBody>
       </p:sp>
@@ -6616,6 +7192,54 @@
               <a:t>Spec-Driven Development with Agentic AI</a:t>
             </a:r>
             <a:endParaRPr lang="en-US" sz="1000" dirty="0"/>
+          </a:p>
+        </p:txBody>
+      </p:sp>
+      <p:sp>
+        <p:nvSpPr>
+          <p:cNvPr id="25" name="Slide Number Placeholder 0"/>
+          <p:cNvSpPr>
+            <a:spLocks noGrp="1"/>
+          </p:cNvSpPr>
+          <p:nvPr>
+            <p:ph type="sldNum" sz="quarter" idx="4294967295"/>
+          </p:nvPr>
+        </p:nvSpPr>
+        <p:spPr>
+          <a:xfrm>
+            <a:off x="5821528" y="6473952"/>
+            <a:ext cx="548640" cy="274320"/>
+          </a:xfrm>
+          <a:prstGeom prst="rect">
+            <a:avLst/>
+          </a:prstGeom>
+          <a:extLst>
+            <a:ext uri="{C572A759-6A51-4108-AA02-DFA0A04FC94B}">
+              <ma14:wrappingTextBoxFlag xmlns:ma14="http://schemas.microsoft.com/office/mac/drawingml/2011/main" val="0"/>
+            </a:ext>
+          </a:extLst>
+        </p:spPr>
+        <p:txBody>
+          <a:bodyPr anchor="ctr"/>
+          <a:lstStyle>
+            <a:lvl1pPr>
+              <a:defRPr sz="1000">
+                <a:solidFill>
+                  <a:srgbClr val="5A6B85"/>
+                </a:solidFill>
+                <a:latin typeface="Calibri"/>
+                <a:ea typeface="Calibri"/>
+                <a:cs typeface="Calibri"/>
+              </a:defRPr>
+            </a:lvl1pPr>
+          </a:lstStyle>
+          <a:p>
+            <a:pPr algn="ctr"/>
+            <a:fld id="{F7021451-1387-4CA6-816F-3879F97B5CBC}" type="slidenum">
+              <a:rPr b="0" lang="en-US"/>
+              <a:t>9</a:t>
+            </a:fld>
+            <a:endParaRPr lang="en-US"/>
           </a:p>
         </p:txBody>
       </p:sp>

</xml_diff>

<commit_message>
mcp-setup.md: add Atlassian (Jira+Confluence) as primary MCP tool, GitHub as secondary cross-reference; Module 2 Step 3 updated to match
Co-Authored-By: Claude Sonnet 5 <noreply@anthropic.com>
</commit_message>
<xml_diff>
--- a/presentation/Module-1_From-Vibe-Coding-to-Spec-Driven-Development.pptx
+++ b/presentation/Module-1_From-Vibe-Coding-to-Spec-Driven-Development.pptx
@@ -3277,7 +3277,7 @@
                 <a:ea typeface="Calibri" pitchFamily="34" charset="-122"/>
                 <a:cs typeface="Calibri" pitchFamily="34" charset="-120"/>
               </a:rPr>
-              <a:t>Ad hoc prompting fails in predictable, nameable ways.</a:t>
+              <a:t>Ad hoc prompting fails in predictable, nameable ways, which means those failures are also predictably preventable.</a:t>
             </a:r>
             <a:endParaRPr lang="en-US" sz="1700" dirty="0"/>
           </a:p>
@@ -3336,7 +3336,7 @@
                 <a:ea typeface="Calibri" pitchFamily="34" charset="-122"/>
                 <a:cs typeface="Calibri" pitchFamily="34" charset="-120"/>
               </a:rPr>
-              <a:t>SDD's core move: make the spec the source of truth, not an afterthought.</a:t>
+              <a:t>SDD's core move: make the spec the source of truth, not an afterthought written up after the code already exists.</a:t>
             </a:r>
             <a:endParaRPr lang="en-US" sz="1700" dirty="0"/>
           </a:p>
@@ -3395,7 +3395,7 @@
                 <a:ea typeface="Calibri" pitchFamily="34" charset="-122"/>
                 <a:cs typeface="Calibri" pitchFamily="34" charset="-120"/>
               </a:rPr>
-              <a:t>You now have both frameworks scaffolded and ready to use for the rest of the course.</a:t>
+              <a:t>You now have both frameworks scaffolded and ready to use for the rest of the course, so every later hands-on exercise builds on this same setup.</a:t>
             </a:r>
             <a:endParaRPr lang="en-US" sz="1700" dirty="0"/>
           </a:p>
@@ -4315,7 +4315,7 @@
                 <a:ea typeface="Calibri" pitchFamily="34" charset="-122"/>
                 <a:cs typeface="Calibri" pitchFamily="34" charset="-120"/>
               </a:rPr>
-              <a:t>the agent gradually loses track of what it's building as a conversation grows longer.</a:t>
+              <a:t>the agent gradually loses track of what it's building as a conversation grows longer, so later output stops matching the original ask.</a:t>
             </a:r>
             <a:endParaRPr lang="en-US" sz="1500" dirty="0"/>
           </a:p>
@@ -4410,7 +4410,7 @@
                 <a:ea typeface="Calibri" pitchFamily="34" charset="-122"/>
                 <a:cs typeface="Calibri" pitchFamily="34" charset="-120"/>
               </a:rPr>
-              <a:t>confident code written against methods, endpoints, or libraries that don't actually exist.</a:t>
+              <a:t>confident code written against methods, endpoints, or libraries that don't actually exist, because nothing forced the agent to check them against a real contract.</a:t>
             </a:r>
             <a:endParaRPr lang="en-US" sz="1500" dirty="0"/>
           </a:p>
@@ -4505,7 +4505,7 @@
                 <a:ea typeface="Calibri" pitchFamily="34" charset="-122"/>
                 <a:cs typeface="Calibri" pitchFamily="34" charset="-120"/>
               </a:rPr>
-              <a:t>large, sprawling changes with no clear boundary to review against.</a:t>
+              <a:t>large, sprawling changes with no clear boundary to review against, so a reviewer can't tell what "done" was supposed to look like.</a:t>
             </a:r>
             <a:endParaRPr lang="en-US" sz="1500" dirty="0"/>
           </a:p>
@@ -4600,7 +4600,7 @@
                 <a:ea typeface="Calibri" pitchFamily="34" charset="-122"/>
                 <a:cs typeface="Calibri" pitchFamily="34" charset="-120"/>
               </a:rPr>
-              <a:t>the agent quietly does more, or less, than what was actually asked.</a:t>
+              <a:t>the agent quietly does more, or less, than what was actually asked, and nobody notices until it ships.</a:t>
             </a:r>
             <a:endParaRPr lang="en-US" sz="1500" dirty="0"/>
           </a:p>
@@ -4917,7 +4917,7 @@
                 <a:ea typeface="Calibri" pitchFamily="34" charset="-122"/>
                 <a:cs typeface="Calibri" pitchFamily="34" charset="-120"/>
               </a:rPr>
-              <a:t>The specification, not the code, is the source artifact.</a:t>
+              <a:t>The specification, not the code, is the source artifact: it's what the team agrees to before anything gets built.</a:t>
             </a:r>
             <a:endParaRPr lang="en-US" sz="1500" dirty="0"/>
           </a:p>
@@ -4998,7 +4998,7 @@
                 <a:ea typeface="Calibri" pitchFamily="34" charset="-122"/>
                 <a:cs typeface="Calibri" pitchFamily="34" charset="-120"/>
               </a:rPr>
-              <a:t>Code becomes a build output generated from that source.</a:t>
+              <a:t>Code becomes a build output generated from that source, similar to how a compiler turns source code into a binary.</a:t>
             </a:r>
             <a:endParaRPr lang="en-US" sz="1500" dirty="0"/>
           </a:p>
@@ -5079,7 +5079,7 @@
                 <a:ea typeface="Calibri" pitchFamily="34" charset="-122"/>
                 <a:cs typeface="Calibri" pitchFamily="34" charset="-120"/>
               </a:rPr>
-              <a:t>This flips the usual relationship: instead of code as truth and docs as commentary, the spec is truth and code is compiled from it.</a:t>
+              <a:t>This flips the usual relationship: instead of code as truth and docs as commentary, the spec is truth and code is compiled from it, so the spec can't quietly fall out of date.</a:t>
             </a:r>
             <a:endParaRPr lang="en-US" sz="1500" dirty="0"/>
           </a:p>
@@ -5160,7 +5160,7 @@
                 <a:ea typeface="Calibri" pitchFamily="34" charset="-122"/>
                 <a:cs typeface="Calibri" pitchFamily="34" charset="-120"/>
               </a:rPr>
-              <a:t>Because the spec persists and stays current, it doubles as living documentation and an audit trail.</a:t>
+              <a:t>Because the spec persists and stays current, it doubles as living documentation and an audit trail, answering "why was this built this way" months later.</a:t>
             </a:r>
             <a:endParaRPr lang="en-US" sz="1500" dirty="0"/>
           </a:p>
@@ -5457,7 +5457,7 @@
                 <a:ea typeface="Calibri" pitchFamily="34" charset="-122"/>
                 <a:cs typeface="Calibri" pitchFamily="34" charset="-120"/>
               </a:rPr>
-              <a:t>GitHub Spec Kit, OpenSpec, Kiro, BMAD-METHOD, and Tessl all put a written spec ahead of code.</a:t>
+              <a:t>GitHub Spec Kit, OpenSpec, Kiro, BMAD-METHOD, and Tessl all put a written spec ahead of code: they differ in mechanics and tooling, not in this underlying philosophy.</a:t>
             </a:r>
             <a:endParaRPr lang="en-US" sz="1500" dirty="0"/>
           </a:p>
@@ -5518,7 +5518,7 @@
                 <a:ea typeface="Calibri" pitchFamily="34" charset="-122"/>
                 <a:cs typeface="Calibri" pitchFamily="34" charset="-120"/>
               </a:rPr>
-              <a:t>This course uses Spec Kit as the hands-on framework for its vendor-neutral, CLI-first design, with a side-by-side look at OpenSpec today.</a:t>
+              <a:t>This course uses Spec Kit as the hands-on framework for its vendor-neutral, CLI-first design, with a side-by-side look at OpenSpec today, so you can recognize the same pattern no matter which tool your team ends up choosing.</a:t>
             </a:r>
             <a:endParaRPr lang="en-US" sz="1500" dirty="0"/>
           </a:p>
@@ -5526,36 +5526,14 @@
       </p:sp>
       <p:sp>
         <p:nvSpPr>
-          <p:cNvPr id="8" name="Shape 6"/>
-          <p:cNvSpPr/>
-          <p:nvPr/>
-        </p:nvSpPr>
-        <p:spPr>
-          <a:xfrm>
-            <a:off x="548640" y="4754880"/>
-            <a:ext cx="11094415" cy="713232"/>
-          </a:xfrm>
-          <a:prstGeom prst="roundRect">
-            <a:avLst>
-              <a:gd name="adj" fmla="val 10256"/>
-            </a:avLst>
-          </a:prstGeom>
-          <a:solidFill>
-            <a:srgbClr val="233A63"/>
-          </a:solidFill>
-          <a:ln/>
-        </p:spPr>
-      </p:sp>
-      <p:sp>
-        <p:nvSpPr>
-          <p:cNvPr id="9" name="Text 7"/>
-          <p:cNvSpPr/>
-          <p:nvPr/>
-        </p:nvSpPr>
-        <p:spPr>
-          <a:xfrm>
-            <a:off x="822960" y="4754880"/>
-            <a:ext cx="10545775" cy="713232"/>
+          <p:cNvPr id="8" name="Text 6"/>
+          <p:cNvSpPr/>
+          <p:nvPr/>
+        </p:nvSpPr>
+        <p:spPr>
+          <a:xfrm>
+            <a:off x="548640" y="6473952"/>
+            <a:ext cx="5486400" cy="274320"/>
           </a:xfrm>
           <a:prstGeom prst="rect">
             <a:avLst/>
@@ -5567,57 +5545,18 @@
           <a:bodyPr wrap="square" rtlCol="0" anchor="ctr"/>
           <a:lstStyle/>
           <a:p>
-            <a:pPr indent="0" marL="0">
-              <a:buNone/>
-            </a:pPr>
-            <a:r>
-              <a:rPr lang="en-US" sz="1500" dirty="0">
-                <a:solidFill>
-                  <a:srgbClr val="E4ECFA"/>
+            <a:pPr algn="l" indent="0" marL="0">
+              <a:buNone/>
+            </a:pPr>
+            <a:r>
+              <a:rPr lang="en-US" sz="1000" dirty="0">
+                <a:solidFill>
+                  <a:srgbClr val="8CA3C7"/>
                 </a:solidFill>
                 <a:latin typeface="Calibri" pitchFamily="34" charset="0"/>
                 <a:ea typeface="Calibri" pitchFamily="34" charset="-122"/>
                 <a:cs typeface="Calibri" pitchFamily="34" charset="-120"/>
               </a:rPr>
-              <a:t>Neither framework requires a specific AI coding agent: both work with GitHub Copilot, Claude Code, and others.</a:t>
-            </a:r>
-            <a:endParaRPr lang="en-US" sz="1500" dirty="0"/>
-          </a:p>
-        </p:txBody>
-      </p:sp>
-      <p:sp>
-        <p:nvSpPr>
-          <p:cNvPr id="10" name="Text 8"/>
-          <p:cNvSpPr/>
-          <p:nvPr/>
-        </p:nvSpPr>
-        <p:spPr>
-          <a:xfrm>
-            <a:off x="548640" y="6473952"/>
-            <a:ext cx="5486400" cy="274320"/>
-          </a:xfrm>
-          <a:prstGeom prst="rect">
-            <a:avLst/>
-          </a:prstGeom>
-          <a:noFill/>
-          <a:ln/>
-        </p:spPr>
-        <p:txBody>
-          <a:bodyPr wrap="square" rtlCol="0" anchor="ctr"/>
-          <a:lstStyle/>
-          <a:p>
-            <a:pPr algn="l" indent="0" marL="0">
-              <a:buNone/>
-            </a:pPr>
-            <a:r>
-              <a:rPr lang="en-US" sz="1000" dirty="0">
-                <a:solidFill>
-                  <a:srgbClr val="8CA3C7"/>
-                </a:solidFill>
-                <a:latin typeface="Calibri" pitchFamily="34" charset="0"/>
-                <a:ea typeface="Calibri" pitchFamily="34" charset="-122"/>
-                <a:cs typeface="Calibri" pitchFamily="34" charset="-120"/>
-              </a:rPr>
               <a:t>Module 1</a:t>
             </a:r>
             <a:endParaRPr lang="en-US" sz="1000" dirty="0"/>
@@ -5626,7 +5565,7 @@
       </p:sp>
       <p:sp>
         <p:nvSpPr>
-          <p:cNvPr id="11" name="Text 9"/>
+          <p:cNvPr id="9" name="Text 7"/>
           <p:cNvSpPr/>
           <p:nvPr/>
         </p:nvSpPr>
@@ -6195,7 +6134,7 @@
                 <a:ea typeface="Calibri" pitchFamily="34" charset="-122"/>
                 <a:cs typeface="Calibri" pitchFamily="34" charset="-120"/>
               </a:rPr>
-              <a:t>Scaffolds a new project: creates .specify/ with templates, scripts, and agent-specific command files. Use --integration copilot or --integration claude to target your agent.</a:t>
+              <a:t>Scaffolds a new project: creates .specify/ with templates, scripts, and agent-specific command files. Use --integration copilot or --integration claude to target your agent, so the generated commands match the tool you'll actually run them in.</a:t>
             </a:r>
             <a:endParaRPr lang="en-US" sz="1350" dirty="0"/>
           </a:p>
@@ -6270,7 +6209,7 @@
                 <a:ea typeface="Calibri" pitchFamily="34" charset="-122"/>
                 <a:cs typeface="Calibri" pitchFamily="34" charset="-120"/>
               </a:rPr>
-              <a:t>The full SDD lifecycle this course follows: constitution, specify, clarify, plan, tasks, checklist, analyze, implement. This is the map for the rest of the course.</a:t>
+              <a:t>The full SDD lifecycle this course follows: constitution, specify, clarify, plan, tasks, checklist, analyze, implement. This is the map for the rest of the course, so every later module is really a deep dive on one step of this same sequence.</a:t>
             </a:r>
             <a:endParaRPr lang="en-US" sz="1400" dirty="0"/>
           </a:p>
@@ -6345,7 +6284,7 @@
                 <a:ea typeface="Calibri" pitchFamily="34" charset="-122"/>
                 <a:cs typeface="Calibri" pitchFamily="34" charset="-120"/>
               </a:rPr>
-              <a:t>Only specify is strictly required before plan. Clarify, checklist, and analyze are quality gates you add for anything with meaningful ambiguity.</a:t>
+              <a:t>Only specify is strictly required before plan. Clarify, checklist, and analyze are quality gates you add for anything with meaningful ambiguity, so simple, low-risk changes don't have to pay for gates they don't need.</a:t>
             </a:r>
             <a:endParaRPr lang="en-US" sz="1400" dirty="0"/>
           </a:p>
@@ -6961,7 +6900,7 @@
                 <a:ea typeface="Calibri" pitchFamily="34" charset="-122"/>
                 <a:cs typeface="Calibri" pitchFamily="34" charset="-120"/>
               </a:rPr>
-              <a:t>Scaffolds openspec/ with specs/ (source of truth), changes/ (proposed updates), and config.yaml. Install first with npm install -g @fission-ai/openspec.</a:t>
+              <a:t>Scaffolds openspec/ with specs/ (source of truth), changes/ (proposed updates), and config.yaml. Install first with npm install -g @fission-ai/openspec, since the CLI has to exist locally before it can scaffold anything.</a:t>
             </a:r>
             <a:endParaRPr lang="en-US" sz="1350" dirty="0"/>
           </a:p>
@@ -7036,7 +6975,7 @@
                 <a:ea typeface="Calibri" pitchFamily="34" charset="-122"/>
                 <a:cs typeface="Calibri" pitchFamily="34" charset="-120"/>
               </a:rPr>
-              <a:t>Default quick path: explore (optional), propose, apply, sync (optional), archive.</a:t>
+              <a:t>Default quick path: explore (optional), propose, apply, sync (optional), archive, so a small change can move through in four commands while a riskier one can add explore and sync for extra checkpoints.</a:t>
             </a:r>
             <a:endParaRPr lang="en-US" sz="1400" dirty="0"/>
           </a:p>
@@ -7111,7 +7050,7 @@
                 <a:ea typeface="Calibri" pitchFamily="34" charset="-122"/>
                 <a:cs typeface="Calibri" pitchFamily="34" charset="-120"/>
               </a:rPr>
-              <a:t>Where Spec Kit produces one spec file per feature, OpenSpec proposes changes as compact deltas (ADDED, MODIFIED, REMOVED) against a single living spec.</a:t>
+              <a:t>Where Spec Kit produces one spec file per feature, OpenSpec proposes changes as compact deltas (ADDED, MODIFIED, REMOVED) against a single living spec, which is why OpenSpec's spec directory stays smaller over time even as the project grows.</a:t>
             </a:r>
             <a:endParaRPr lang="en-US" sz="1400" dirty="0"/>
           </a:p>

</xml_diff>